<commit_message>
Add Commuter Mobile App UI photos & 26-slide Vishwakarma presentation deck
</commit_message>
<xml_diff>
--- a/presentation/RainRoute_Vishwakarma_Stage2_Deck.pptx
+++ b/presentation/RainRoute_Vishwakarma_Stage2_Deck.pptx
@@ -30,6 +30,7 @@
     <p:sldId id="278" r:id="rId29"/>
     <p:sldId id="279" r:id="rId30"/>
     <p:sldId id="280" r:id="rId31"/>
+    <p:sldId id="281" r:id="rId32"/>
   </p:sldIdLst>
   <p:sldSz cx="12191695" cy="6858000" type="screen4x3"/>
   <p:notesSz cx="6858000" cy="9144000"/>
@@ -13275,6 +13276,505 @@
 </p:sld>
 </file>
 
+<file path=ppt/slides/slide26.xml><?xml version="1.0" encoding="utf-8"?>
+<p:sld xmlns:a="http://schemas.openxmlformats.org/drawingml/2006/main" xmlns:p="http://schemas.openxmlformats.org/presentationml/2006/main" xmlns:r="http://schemas.openxmlformats.org/officeDocument/2006/relationships">
+  <p:cSld>
+    <p:spTree>
+      <p:nvGrpSpPr>
+        <p:cNvPr id="1" name=""/>
+        <p:cNvGrpSpPr/>
+        <p:nvPr/>
+      </p:nvGrpSpPr>
+      <p:grpSpPr/>
+      <p:pic>
+        <p:nvPicPr>
+          <p:cNvPr id="2" name="Picture 1" descr="image.png"/>
+          <p:cNvPicPr>
+            <a:picLocks noChangeAspect="1"/>
+          </p:cNvPicPr>
+          <p:nvPr/>
+        </p:nvPicPr>
+        <p:blipFill>
+          <a:blip r:embed="rId2"/>
+          <a:stretch>
+            <a:fillRect/>
+          </a:stretch>
+        </p:blipFill>
+        <p:spPr>
+          <a:xfrm>
+            <a:off x="0" y="0"/>
+            <a:ext cx="12191695" cy="868680"/>
+          </a:xfrm>
+          <a:prstGeom prst="rect">
+            <a:avLst/>
+          </a:prstGeom>
+        </p:spPr>
+      </p:pic>
+      <p:sp>
+        <p:nvSpPr>
+          <p:cNvPr id="3" name="Rounded Rectangle 2"/>
+          <p:cNvSpPr/>
+          <p:nvPr/>
+        </p:nvSpPr>
+        <p:spPr>
+          <a:xfrm>
+            <a:off x="731520" y="960120"/>
+            <a:ext cx="4400000" cy="320040"/>
+          </a:xfrm>
+          <a:prstGeom prst="roundRect">
+            <a:avLst/>
+          </a:prstGeom>
+          <a:solidFill>
+            <a:srgbClr val="E0F2FE"/>
+          </a:solidFill>
+          <a:ln w="12700">
+            <a:solidFill>
+              <a:srgbClr val="0277BD"/>
+            </a:solidFill>
+          </a:ln>
+        </p:spPr>
+        <p:style>
+          <a:lnRef idx="1">
+            <a:schemeClr val="accent1"/>
+          </a:lnRef>
+          <a:fillRef idx="3">
+            <a:schemeClr val="accent1"/>
+          </a:fillRef>
+          <a:effectRef idx="2">
+            <a:schemeClr val="accent1"/>
+          </a:effectRef>
+          <a:fontRef idx="minor">
+            <a:schemeClr val="lt1"/>
+          </a:fontRef>
+        </p:style>
+        <p:txBody>
+          <a:bodyPr rtlCol="0" anchor="ctr" wrap="square"/>
+          <a:lstStyle/>
+          <a:p>
+            <a:pPr algn="ctr">
+              <a:defRPr sz="950" b="1">
+                <a:solidFill>
+                  <a:srgbClr val="0277BD"/>
+                </a:solidFill>
+              </a:defRPr>
+            </a:pPr>
+            <a:r>
+              <a:t>COMMUTER MOBILE APPLICATION (FLUTTER UX)</a:t>
+            </a:r>
+          </a:p>
+        </p:txBody>
+      </p:sp>
+      <p:sp>
+        <p:nvSpPr>
+          <p:cNvPr id="4" name="TextBox 3"/>
+          <p:cNvSpPr txBox="1"/>
+          <p:nvPr/>
+        </p:nvSpPr>
+        <p:spPr>
+          <a:xfrm>
+            <a:off x="6858000" y="932688"/>
+            <a:ext cx="4572000" cy="365760"/>
+          </a:xfrm>
+          <a:prstGeom prst="rect">
+            <a:avLst/>
+          </a:prstGeom>
+          <a:noFill/>
+        </p:spPr>
+        <p:txBody>
+          <a:bodyPr wrap="square">
+            <a:spAutoFit/>
+          </a:bodyPr>
+          <a:lstStyle/>
+          <a:p>
+            <a:pPr algn="r">
+              <a:defRPr sz="950" b="1">
+                <a:solidFill>
+                  <a:srgbClr val="0F2341"/>
+                </a:solidFill>
+              </a:defRPr>
+            </a:pPr>
+            <a:r>
+              <a:t>APP ID: VK26-IITH-SC-0552 | TRACK: SUSTAINABLE CITIES</a:t>
+            </a:r>
+          </a:p>
+        </p:txBody>
+      </p:sp>
+      <p:sp>
+        <p:nvSpPr>
+          <p:cNvPr id="5" name="TextBox 4"/>
+          <p:cNvSpPr txBox="1"/>
+          <p:nvPr/>
+        </p:nvSpPr>
+        <p:spPr>
+          <a:xfrm>
+            <a:off x="731520" y="1325880"/>
+            <a:ext cx="10789920" cy="594360"/>
+          </a:xfrm>
+          <a:prstGeom prst="rect">
+            <a:avLst/>
+          </a:prstGeom>
+          <a:noFill/>
+        </p:spPr>
+        <p:txBody>
+          <a:bodyPr wrap="square">
+            <a:spAutoFit/>
+          </a:bodyPr>
+          <a:lstStyle/>
+          <a:p>
+            <a:pPr>
+              <a:defRPr sz="1700" b="1">
+                <a:solidFill>
+                  <a:srgbClr val="0F2341"/>
+                </a:solidFill>
+              </a:defRPr>
+            </a:pPr>
+            <a:r>
+              <a:t>Cross-Platform Commuter Mobile Application &amp; Real-Time Alert UI</a:t>
+            </a:r>
+          </a:p>
+          <a:p>
+            <a:pPr>
+              <a:defRPr sz="1000">
+                <a:solidFill>
+                  <a:srgbClr val="64748B"/>
+                </a:solidFill>
+              </a:defRPr>
+            </a:pPr>
+            <a:r>
+              <a:t>Vehicle-Stratified Hydrolock Advisory, Manhole Displacement Warning &amp; Zero-Data BLE UX</a:t>
+            </a:r>
+          </a:p>
+        </p:txBody>
+      </p:sp>
+      <p:pic>
+        <p:nvPicPr>
+          <p:cNvPr id="6" name="Picture 5" descr="image.png"/>
+          <p:cNvPicPr>
+            <a:picLocks noChangeAspect="1"/>
+          </p:cNvPicPr>
+          <p:nvPr/>
+        </p:nvPicPr>
+        <p:blipFill>
+          <a:blip r:embed="rId3"/>
+          <a:stretch>
+            <a:fillRect/>
+          </a:stretch>
+        </p:blipFill>
+        <p:spPr>
+          <a:xfrm>
+            <a:off x="0" y="6263640"/>
+            <a:ext cx="1645920" cy="502920"/>
+          </a:xfrm>
+          <a:prstGeom prst="rect">
+            <a:avLst/>
+          </a:prstGeom>
+        </p:spPr>
+      </p:pic>
+      <p:pic>
+        <p:nvPicPr>
+          <p:cNvPr id="7" name="Picture 6" descr="image.png"/>
+          <p:cNvPicPr>
+            <a:picLocks noChangeAspect="1"/>
+          </p:cNvPicPr>
+          <p:nvPr/>
+        </p:nvPicPr>
+        <p:blipFill>
+          <a:blip r:embed="rId4"/>
+          <a:stretch>
+            <a:fillRect/>
+          </a:stretch>
+        </p:blipFill>
+        <p:spPr>
+          <a:xfrm>
+            <a:off x="11064240" y="6263640"/>
+            <a:ext cx="1051560" cy="502920"/>
+          </a:xfrm>
+          <a:prstGeom prst="rect">
+            <a:avLst/>
+          </a:prstGeom>
+        </p:spPr>
+      </p:pic>
+      <p:pic>
+        <p:nvPicPr>
+          <p:cNvPr id="8" name="Picture 7" descr="rainroute_mobile_app_ui.png"/>
+          <p:cNvPicPr>
+            <a:picLocks noChangeAspect="1"/>
+          </p:cNvPicPr>
+          <p:nvPr/>
+        </p:nvPicPr>
+        <p:blipFill>
+          <a:blip r:embed="rId5"/>
+          <a:stretch>
+            <a:fillRect/>
+          </a:stretch>
+        </p:blipFill>
+        <p:spPr>
+          <a:xfrm>
+            <a:off x="731520" y="2011680"/>
+            <a:ext cx="6000000" cy="3642987"/>
+          </a:xfrm>
+          <a:prstGeom prst="rect">
+            <a:avLst/>
+          </a:prstGeom>
+        </p:spPr>
+      </p:pic>
+      <p:sp>
+        <p:nvSpPr>
+          <p:cNvPr id="9" name="Rounded Rectangle 8"/>
+          <p:cNvSpPr/>
+          <p:nvPr/>
+        </p:nvSpPr>
+        <p:spPr>
+          <a:xfrm>
+            <a:off x="6900000" y="2011680"/>
+            <a:ext cx="4560000" cy="4114800"/>
+          </a:xfrm>
+          <a:prstGeom prst="roundRect">
+            <a:avLst/>
+          </a:prstGeom>
+          <a:solidFill>
+            <a:srgbClr val="F8FAFC"/>
+          </a:solidFill>
+          <a:ln w="12700">
+            <a:solidFill>
+              <a:srgbClr val="CBD5E1"/>
+            </a:solidFill>
+          </a:ln>
+        </p:spPr>
+        <p:style>
+          <a:lnRef idx="1">
+            <a:schemeClr val="accent1"/>
+          </a:lnRef>
+          <a:fillRef idx="3">
+            <a:schemeClr val="accent1"/>
+          </a:fillRef>
+          <a:effectRef idx="2">
+            <a:schemeClr val="accent1"/>
+          </a:effectRef>
+          <a:fontRef idx="minor">
+            <a:schemeClr val="lt1"/>
+          </a:fontRef>
+        </p:style>
+        <p:txBody>
+          <a:bodyPr rtlCol="0" anchor="ctr" wrap="square" lIns="182880" rIns="182880" tIns="182880" bIns="182880"/>
+          <a:lstStyle/>
+          <a:p>
+            <a:pPr algn="ctr">
+              <a:defRPr sz="1100" b="1">
+                <a:solidFill>
+                  <a:srgbClr val="0F2341"/>
+                </a:solidFill>
+              </a:defRPr>
+            </a:pPr>
+            <a:r>
+              <a:t>Core UI Screens &amp; Commuter UX Architecture</a:t>
+            </a:r>
+          </a:p>
+          <a:p>
+            <a:pPr>
+              <a:spcBef>
+                <a:spcPts val="400"/>
+              </a:spcBef>
+              <a:defRPr sz="950" b="1">
+                <a:solidFill>
+                  <a:srgbClr val="0277BD"/>
+                </a:solidFill>
+              </a:defRPr>
+            </a:pPr>
+            <a:r>
+              <a:t>Screen 1: Dynamic Hydrolock Navigator</a:t>
+            </a:r>
+          </a:p>
+          <a:p>
+            <a:pPr>
+              <a:spcBef>
+                <a:spcPts val="100"/>
+              </a:spcBef>
+              <a:defRPr sz="850" b="0">
+                <a:solidFill>
+                  <a:srgbClr val="1E293B"/>
+                </a:solidFill>
+              </a:defRPr>
+            </a:pPr>
+            <a:r>
+              <a:t>• Vehicle Clearance Profiler: Stratified risk engine allows commuters to select vehicle profile (2-Wheeler: 150mm exhaust limit | Car: 250mm | Transit Bus: 450mm).</a:t>
+            </a:r>
+          </a:p>
+          <a:p>
+            <a:pPr>
+              <a:spcBef>
+                <a:spcPts val="100"/>
+              </a:spcBef>
+              <a:defRPr sz="850" b="0">
+                <a:solidFill>
+                  <a:srgbClr val="1E293B"/>
+                </a:solidFill>
+              </a:defRPr>
+            </a:pPr>
+            <a:r>
+              <a:t>• Dynamic Detour Engine: Color-coded vector map detects waterlogged underpasses (Red &gt;150mm) and computes real-time flyover bypass (+3.2 min delta).</a:t>
+            </a:r>
+          </a:p>
+          <a:p>
+            <a:pPr>
+              <a:spcBef>
+                <a:spcPts val="100"/>
+              </a:spcBef>
+              <a:defRPr sz="850" b="0">
+                <a:solidFill>
+                  <a:srgbClr val="1E293B"/>
+                </a:solidFill>
+              </a:defRPr>
+            </a:pPr>
+            <a:r>
+              <a:t>• Hydrolock Advisory Card: Computes exact submersion risk (+90mm over exhaust pipe) to prevent catastrophic engine seizure before entry.</a:t>
+            </a:r>
+          </a:p>
+          <a:p>
+            <a:pPr>
+              <a:spcBef>
+                <a:spcPts val="400"/>
+              </a:spcBef>
+              <a:defRPr sz="950" b="1">
+                <a:solidFill>
+                  <a:srgbClr val="DC2626"/>
+                </a:solidFill>
+              </a:defRPr>
+            </a:pPr>
+            <a:r>
+              <a:t>Screen 2: Manhole Displacement Warning Modal</a:t>
+            </a:r>
+          </a:p>
+          <a:p>
+            <a:pPr>
+              <a:spcBef>
+                <a:spcPts val="100"/>
+              </a:spcBef>
+              <a:defRPr sz="850" b="0">
+                <a:solidFill>
+                  <a:srgbClr val="1E293B"/>
+                </a:solidFill>
+              </a:defRPr>
+            </a:pPr>
+            <a:r>
+              <a:t>• Instant Hazard Interrupt: Triggered within &lt;500ms when roadside pod detects &gt;15° lid tilt or &gt;0.3g displacement impact shock.</a:t>
+            </a:r>
+          </a:p>
+          <a:p>
+            <a:pPr>
+              <a:spcBef>
+                <a:spcPts val="100"/>
+              </a:spcBef>
+              <a:defRPr sz="850" b="0">
+                <a:solidFill>
+                  <a:srgbClr val="1E293B"/>
+                </a:solidFill>
+              </a:defRPr>
+            </a:pPr>
+            <a:r>
+              <a:t>• Lane Action Directive: Displays distance (110m) and mandates: 'MERGE RIGHT TO CENTER LANE NOW' to prevent fatal falls.</a:t>
+            </a:r>
+          </a:p>
+          <a:p>
+            <a:pPr>
+              <a:spcBef>
+                <a:spcPts val="100"/>
+              </a:spcBef>
+              <a:defRPr sz="850" b="0">
+                <a:solidFill>
+                  <a:srgbClr val="1E293B"/>
+                </a:solidFill>
+              </a:defRPr>
+            </a:pPr>
+            <a:r>
+              <a:t>• Binaural Haptic Alert: Transmits vibration pattern and voice prompt directly to rider's Bluetooth helmet communicator or phone.</a:t>
+            </a:r>
+          </a:p>
+          <a:p>
+            <a:pPr>
+              <a:spcBef>
+                <a:spcPts val="400"/>
+              </a:spcBef>
+              <a:defRPr sz="950" b="1">
+                <a:solidFill>
+                  <a:srgbClr val="B45309"/>
+                </a:solidFill>
+              </a:defRPr>
+            </a:pPr>
+            <a:r>
+              <a:t>Screen 3: Zero-Data Offline BLE Emergency UX</a:t>
+            </a:r>
+          </a:p>
+          <a:p>
+            <a:pPr>
+              <a:spcBef>
+                <a:spcPts val="100"/>
+              </a:spcBef>
+              <a:defRPr sz="850" b="0">
+                <a:solidFill>
+                  <a:srgbClr val="1E293B"/>
+                </a:solidFill>
+              </a:defRPr>
+            </a:pPr>
+            <a:r>
+              <a:t>• Hardware-Level Beaconing: Passing commuters receive direct BLE Eddystone push notifications within 80m without SIM signal, active 4G/5G, or cellular data.</a:t>
+            </a:r>
+          </a:p>
+          <a:p>
+            <a:pPr>
+              <a:spcBef>
+                <a:spcPts val="100"/>
+              </a:spcBef>
+              <a:defRPr sz="850" b="0">
+                <a:solidFill>
+                  <a:srgbClr val="1E293B"/>
+                </a:solidFill>
+              </a:defRPr>
+            </a:pPr>
+            <a:r>
+              <a:t>• Wi-Fi Emergency SSID: ESP32 broadcasts '! WARNING: UNDERPASS FLOODED (310mm) - DIVERT !' directly visible in phone Wi-Fi settings.</a:t>
+            </a:r>
+          </a:p>
+          <a:p>
+            <a:pPr>
+              <a:spcBef>
+                <a:spcPts val="400"/>
+              </a:spcBef>
+              <a:defRPr sz="950" b="1">
+                <a:solidFill>
+                  <a:srgbClr val="0F766E"/>
+                </a:solidFill>
+              </a:defRPr>
+            </a:pPr>
+            <a:r>
+              <a:t>Cross-Platform Tech Stack &amp; Performance</a:t>
+            </a:r>
+          </a:p>
+          <a:p>
+            <a:pPr>
+              <a:spcBef>
+                <a:spcPts val="100"/>
+              </a:spcBef>
+              <a:defRPr sz="850" b="0">
+                <a:solidFill>
+                  <a:srgbClr val="1E293B"/>
+                </a:solidFill>
+              </a:defRPr>
+            </a:pPr>
+            <a:r>
+              <a:t>• Flutter (Dart) for Android &amp; iOS; Google Cloud Firestore live synchronization (&lt;500ms latency); battery footprint &lt;1.8%/hr.</a:t>
+            </a:r>
+          </a:p>
+        </p:txBody>
+      </p:sp>
+    </p:spTree>
+  </p:cSld>
+  <p:clrMapOvr>
+    <a:masterClrMapping/>
+  </p:clrMapOvr>
+</p:sld>
+</file>
+
 <file path=ppt/slides/slide3.xml><?xml version="1.0" encoding="utf-8"?>
 <p:sld xmlns:a="http://schemas.openxmlformats.org/drawingml/2006/main" xmlns:p="http://schemas.openxmlformats.org/presentationml/2006/main" xmlns:r="http://schemas.openxmlformats.org/officeDocument/2006/relationships">
   <p:cSld>

</xml_diff>

<commit_message>
Upgrade to professional 3D studio flagship smartphone UI mockups
</commit_message>
<xml_diff>
--- a/presentation/RainRoute_Vishwakarma_Stage2_Deck.pptx
+++ b/presentation/RainRoute_Vishwakarma_Stage2_Deck.pptx
@@ -13441,7 +13441,7 @@
               </a:defRPr>
             </a:pPr>
             <a:r>
-              <a:t>Vehicle-Stratified Hydrolock Advisory, Manhole Displacement Warning &amp; Zero-Data BLE UX</a:t>
+              <a:t>Production-Grade Flutter Interface: Dynamic Hydrolock Engine, Manhole Hazard HUD &amp; Zero-Data BLE</a:t>
             </a:r>
           </a:p>
         </p:txBody>
@@ -13496,7 +13496,7 @@
       </p:pic>
       <p:pic>
         <p:nvPicPr>
-          <p:cNvPr id="8" name="Picture 7" descr="rainroute_mobile_app_ui.png"/>
+          <p:cNvPr id="8" name="Picture 7" descr="rainroute_mobile_mockup_studio.png"/>
           <p:cNvPicPr>
             <a:picLocks noChangeAspect="1"/>
           </p:cNvPicPr>
@@ -13510,8 +13510,8 @@
         </p:blipFill>
         <p:spPr>
           <a:xfrm>
-            <a:off x="731520" y="2011680"/>
-            <a:ext cx="6000000" cy="3642987"/>
+            <a:off x="731520" y="2050000"/>
+            <a:ext cx="6400000" cy="3573422"/>
           </a:xfrm>
           <a:prstGeom prst="rect">
             <a:avLst/>
@@ -13526,8 +13526,8 @@
         </p:nvSpPr>
         <p:spPr>
           <a:xfrm>
-            <a:off x="6900000" y="2011680"/>
-            <a:ext cx="4560000" cy="4114800"/>
+            <a:off x="7280000" y="2050000"/>
+            <a:ext cx="4180000" cy="4050000"/>
           </a:xfrm>
           <a:prstGeom prst="roundRect">
             <a:avLst/>
@@ -13567,7 +13567,7 @@
               </a:defRPr>
             </a:pPr>
             <a:r>
-              <a:t>Core UI Screens &amp; Commuter UX Architecture</a:t>
+              <a:t>Mobile Application UX &amp; Production Architecture</a:t>
             </a:r>
           </a:p>
           <a:p>
@@ -13582,7 +13582,7 @@
               </a:defRPr>
             </a:pPr>
             <a:r>
-              <a:t>Screen 1: Dynamic Hydrolock Navigator</a:t>
+              <a:t>Screen 1: Dynamic Hydrolock Live Navigator</a:t>
             </a:r>
           </a:p>
           <a:p>
@@ -13597,7 +13597,7 @@
               </a:defRPr>
             </a:pPr>
             <a:r>
-              <a:t>• Vehicle Clearance Profiler: Stratified risk engine allows commuters to select vehicle profile (2-Wheeler: 150mm exhaust limit | Car: 250mm | Transit Bus: 450mm).</a:t>
+              <a:t>• Vehicle Stratification: Selects vehicle type (2-Wheeler: 150mm | Car: 250mm | Bus: 450mm).</a:t>
             </a:r>
           </a:p>
           <a:p>
@@ -13612,7 +13612,7 @@
               </a:defRPr>
             </a:pPr>
             <a:r>
-              <a:t>• Dynamic Detour Engine: Color-coded vector map detects waterlogged underpasses (Red &gt;150mm) and computes real-time flyover bypass (+3.2 min delta).</a:t>
+              <a:t>• Submersion Alert: Warns when water depth exceeds exhaust pipe height before entry.</a:t>
             </a:r>
           </a:p>
           <a:p>
@@ -13627,7 +13627,7 @@
               </a:defRPr>
             </a:pPr>
             <a:r>
-              <a:t>• Hydrolock Advisory Card: Computes exact submersion risk (+90mm over exhaust pipe) to prevent catastrophic engine seizure before entry.</a:t>
+              <a:t>• Automated Rerouting: Computes real-time flyover/bypass detour (+3.2 min delta).</a:t>
             </a:r>
           </a:p>
           <a:p>
@@ -13642,7 +13642,7 @@
               </a:defRPr>
             </a:pPr>
             <a:r>
-              <a:t>Screen 2: Manhole Displacement Warning Modal</a:t>
+              <a:t>Screen 2: Manhole Displacement Hazard HUD</a:t>
             </a:r>
           </a:p>
           <a:p>
@@ -13657,7 +13657,7 @@
               </a:defRPr>
             </a:pPr>
             <a:r>
-              <a:t>• Instant Hazard Interrupt: Triggered within &lt;500ms when roadside pod detects &gt;15° lid tilt or &gt;0.3g displacement impact shock.</a:t>
+              <a:t>• Millisecond Trigger: Activated when roadside pod detects &gt;15° tilt or &gt;0.3g shock.</a:t>
             </a:r>
           </a:p>
           <a:p>
@@ -13672,7 +13672,7 @@
               </a:defRPr>
             </a:pPr>
             <a:r>
-              <a:t>• Lane Action Directive: Displays distance (110m) and mandates: 'MERGE RIGHT TO CENTER LANE NOW' to prevent fatal falls.</a:t>
+              <a:t>• Critical Lane Directive: Mandates 'MERGE RIGHT TO CENTER LANE NOW' (110m warning).</a:t>
             </a:r>
           </a:p>
           <a:p>
@@ -13687,7 +13687,7 @@
               </a:defRPr>
             </a:pPr>
             <a:r>
-              <a:t>• Binaural Haptic Alert: Transmits vibration pattern and voice prompt directly to rider's Bluetooth helmet communicator or phone.</a:t>
+              <a:t>• Binaural Audio/Haptics: Helmet and phone vibration alerts for night monsoon rides.</a:t>
             </a:r>
           </a:p>
           <a:p>
@@ -13717,7 +13717,7 @@
               </a:defRPr>
             </a:pPr>
             <a:r>
-              <a:t>• Hardware-Level Beaconing: Passing commuters receive direct BLE Eddystone push notifications within 80m without SIM signal, active 4G/5G, or cellular data.</a:t>
+              <a:t>• Hardware-Level Beacon: Direct BLE Eddystone alerts within 80m without SIM or data.</a:t>
             </a:r>
           </a:p>
           <a:p>
@@ -13732,7 +13732,7 @@
               </a:defRPr>
             </a:pPr>
             <a:r>
-              <a:t>• Wi-Fi Emergency SSID: ESP32 broadcasts '! WARNING: UNDERPASS FLOODED (310mm) - DIVERT !' directly visible in phone Wi-Fi settings.</a:t>
+              <a:t>• Wi-Fi Emergency SSID: ESP32 broadcasts '! WARNING: UNDERPASS FLOODED (310mm) !'.</a:t>
             </a:r>
           </a:p>
           <a:p>
@@ -13747,7 +13747,7 @@
               </a:defRPr>
             </a:pPr>
             <a:r>
-              <a:t>Cross-Platform Tech Stack &amp; Performance</a:t>
+              <a:t>Tech Stack &amp; Engineering Rigor</a:t>
             </a:r>
           </a:p>
           <a:p>
@@ -13762,7 +13762,7 @@
               </a:defRPr>
             </a:pPr>
             <a:r>
-              <a:t>• Flutter (Dart) for Android &amp; iOS; Google Cloud Firestore live synchronization (&lt;500ms latency); battery footprint &lt;1.8%/hr.</a:t>
+              <a:t>• Flutter (Dart) for Android &amp; iOS; Google Cloud Firestore live stream (&lt;500ms latency); battery impact &lt;1.8%/hr.</a:t>
             </a:r>
           </a:p>
         </p:txBody>

</xml_diff>

<commit_message>
Update Slide 2 Problem Context with official NCRB 2024 manhole casualty data
</commit_message>
<xml_diff>
--- a/presentation/RainRoute_Vishwakarma_Stage2_Deck.pptx
+++ b/presentation/RainRoute_Vishwakarma_Stage2_Deck.pptx
@@ -9991,30 +9991,42 @@
           </a:fontRef>
         </p:style>
         <p:txBody>
-          <a:bodyPr rtlCol="0" anchor="ctr"/>
+          <a:bodyPr rtlCol="0" anchor="ctr" wrap="square"/>
           <a:lstStyle/>
           <a:p>
             <a:pPr algn="ctr">
-              <a:defRPr sz="1900" b="1">
+              <a:defRPr sz="1700" b="1">
                 <a:solidFill>
                   <a:srgbClr val="DC2626"/>
                 </a:solidFill>
               </a:defRPr>
             </a:pPr>
             <a:r>
-              <a:t>&gt;1,500/Yr</a:t>
+              <a:t>192 Deaths/Yr</a:t>
             </a:r>
           </a:p>
           <a:p>
             <a:pPr algn="ctr">
-              <a:defRPr sz="750" b="1">
+              <a:defRPr sz="700" b="1">
                 <a:solidFill>
                   <a:srgbClr val="64748B"/>
                 </a:solidFill>
               </a:defRPr>
             </a:pPr>
             <a:r>
-              <a:t>OPEN MANHOLE CASUALTIES</a:t>
+              <a:t>OPEN MANHOLE CASUALTIES (NCRB)</a:t>
+            </a:r>
+          </a:p>
+          <a:p>
+            <a:pPr>
+              <a:defRPr sz="650">
+                <a:solidFill>
+                  <a:srgbClr val="94A3B8"/>
+                </a:solidFill>
+              </a:defRPr>
+            </a:pPr>
+            <a:r>
+              <a:t>&gt;1,500 Severe Monsoon Injuries</a:t>
             </a:r>
           </a:p>
         </p:txBody>
@@ -10142,62 +10154,62 @@
           </a:p>
           <a:p>
             <a:pPr>
-              <a:spcAft>
-                <a:spcPts val="350"/>
-              </a:spcAft>
-              <a:defRPr sz="900">
-                <a:solidFill>
-                  <a:srgbClr val="1E293B"/>
-                </a:solidFill>
-              </a:defRPr>
-            </a:pPr>
-            <a:r>
-              <a:t>• Two-Wheeler Riders (Micro-Mobility): Ingress &gt;150mm floods exhaust mufflers, seizing engines instantly; EV scooters suffer battery short-circuiting.</a:t>
-            </a:r>
-          </a:p>
-          <a:p>
-            <a:pPr>
-              <a:spcAft>
-                <a:spcPts val="350"/>
-              </a:spcAft>
-              <a:defRPr sz="900">
-                <a:solidFill>
-                  <a:srgbClr val="1E293B"/>
-                </a:solidFill>
-              </a:defRPr>
-            </a:pPr>
-            <a:r>
-              <a:t>• Public Transit Buses (TSRTC/BMTC): Low-floor city buses cannot navigate submerged underpasses, stranding thousands of daily passengers.</a:t>
-            </a:r>
-          </a:p>
-          <a:p>
-            <a:pPr>
-              <a:spcAft>
-                <a:spcPts val="350"/>
-              </a:spcAft>
-              <a:defRPr sz="900">
-                <a:solidFill>
-                  <a:srgbClr val="1E293B"/>
-                </a:solidFill>
-              </a:defRPr>
-            </a:pPr>
-            <a:r>
-              <a:t>• Emergency Services (108 Ambulances): Blind navigation into flooded underpasses traps emergency vehicles with critical patients.</a:t>
-            </a:r>
-          </a:p>
-          <a:p>
-            <a:pPr>
-              <a:spcAft>
-                <a:spcPts val="350"/>
-              </a:spcAft>
-              <a:defRPr sz="900">
-                <a:solidFill>
-                  <a:srgbClr val="1E293B"/>
-                </a:solidFill>
-              </a:defRPr>
-            </a:pPr>
-            <a:r>
-              <a:t>• Gig Delivery Workers: Swiggy/Zomato/Rapido delivery partners lose daily earnings and face fatal falls into submerged open drains.</a:t>
+              <a:spcBef>
+                <a:spcPts val="300"/>
+              </a:spcBef>
+              <a:defRPr sz="850">
+                <a:solidFill>
+                  <a:srgbClr val="1E293B"/>
+                </a:solidFill>
+              </a:defRPr>
+            </a:pPr>
+            <a:r>
+              <a:t>• Two-Wheeler Riders (Micro-Mobility): Ingress &gt;150mm floods exhaust mufflers causing instant hydrolock; submerged open manholes cause fatal front-wheel plunge crashes (192 deaths annually - NCRB).</a:t>
+            </a:r>
+          </a:p>
+          <a:p>
+            <a:pPr>
+              <a:spcBef>
+                <a:spcPts val="300"/>
+              </a:spcBef>
+              <a:defRPr sz="850">
+                <a:solidFill>
+                  <a:srgbClr val="1E293B"/>
+                </a:solidFill>
+              </a:defRPr>
+            </a:pPr>
+            <a:r>
+              <a:t>• Pedestrians &amp; Gig Delivery Workers: Swiggy/Zomato/Rapido partners navigate blind murky water during monsoon downpours; 100-150mm of muddy water completely conceals missing or displaced covers.</a:t>
+            </a:r>
+          </a:p>
+          <a:p>
+            <a:pPr>
+              <a:spcBef>
+                <a:spcPts val="300"/>
+              </a:spcBef>
+              <a:defRPr sz="850">
+                <a:solidFill>
+                  <a:srgbClr val="1E293B"/>
+                </a:solidFill>
+              </a:defRPr>
+            </a:pPr>
+            <a:r>
+              <a:t>• Public Transit Buses (TSRTC/BMTC): Low-floor city buses cannot navigate submerged underpass sag points, stranding thousands of daily passengers and triggering corridor-wide gridlock.</a:t>
+            </a:r>
+          </a:p>
+          <a:p>
+            <a:pPr>
+              <a:spcBef>
+                <a:spcPts val="300"/>
+              </a:spcBef>
+              <a:defRPr sz="850">
+                <a:solidFill>
+                  <a:srgbClr val="1E293B"/>
+                </a:solidFill>
+              </a:defRPr>
+            </a:pPr>
+            <a:r>
+              <a:t>• Emergency Services (108 Ambulances): Blind navigation into flooded underpasses traps emergency medical vehicles with critical cardiac and trauma patients.</a:t>
             </a:r>
           </a:p>
         </p:txBody>
@@ -10259,62 +10271,62 @@
           </a:p>
           <a:p>
             <a:pPr>
-              <a:spcAft>
-                <a:spcPts val="350"/>
-              </a:spcAft>
-              <a:defRPr sz="900">
-                <a:solidFill>
-                  <a:srgbClr val="1E293B"/>
-                </a:solidFill>
-              </a:defRPr>
-            </a:pPr>
-            <a:r>
-              <a:t>• Rapid Underpass Inundation (&lt;20 Mins): In heavy rain, low-elevation underpass sag points drown before traffic police can place physical barricades.</a:t>
-            </a:r>
-          </a:p>
-          <a:p>
-            <a:pPr>
-              <a:spcAft>
-                <a:spcPts val="350"/>
-              </a:spcAft>
-              <a:defRPr sz="900">
-                <a:solidFill>
-                  <a:srgbClr val="1E293B"/>
-                </a:solidFill>
-              </a:defRPr>
-            </a:pPr>
-            <a:r>
-              <a:t>• Submerged Open Manholes: Storm drain hydraulic backpressure blows manhole covers off, creating invisible deathtraps under dirty water.</a:t>
-            </a:r>
-          </a:p>
-          <a:p>
-            <a:pPr>
-              <a:spcAft>
-                <a:spcPts val="350"/>
-              </a:spcAft>
-              <a:defRPr sz="900">
-                <a:solidFill>
-                  <a:srgbClr val="1E293B"/>
-                </a:solidFill>
-              </a:defRPr>
-            </a:pPr>
-            <a:r>
-              <a:t>• Consumer Navigation Deficiency: Google Maps only reflects traffic slowdown after vehicles have already stalled; cannot detect actual water depth.</a:t>
-            </a:r>
-          </a:p>
-          <a:p>
-            <a:pPr>
-              <a:spcAft>
-                <a:spcPts val="350"/>
-              </a:spcAft>
-              <a:defRPr sz="900">
-                <a:solidFill>
-                  <a:srgbClr val="1E293B"/>
-                </a:solidFill>
-              </a:defRPr>
-            </a:pPr>
-            <a:r>
-              <a:t>• Civic Macro-Alert Limitations: City-wide 'Orange/Red' weather alerts do not inform commuters which street dip or underpass is flooded.</a:t>
+              <a:spcBef>
+                <a:spcPts val="300"/>
+              </a:spcBef>
+              <a:defRPr sz="850">
+                <a:solidFill>
+                  <a:srgbClr val="1E293B"/>
+                </a:solidFill>
+              </a:defRPr>
+            </a:pPr>
+            <a:r>
+              <a:t>• Submerged Open Manholes (The Invisible Trap): Storm runoff hydraulic backpressure blows 80kg cast-iron lids off; murky floodwater conceals the exposed chamber, creating lethal hazards with zero warning.</a:t>
+            </a:r>
+          </a:p>
+          <a:p>
+            <a:pPr>
+              <a:spcBef>
+                <a:spcPts val="300"/>
+              </a:spcBef>
+              <a:defRPr sz="850">
+                <a:solidFill>
+                  <a:srgbClr val="1E293B"/>
+                </a:solidFill>
+              </a:defRPr>
+            </a:pPr>
+            <a:r>
+              <a:t>• Rapid Underpass Inundation (&lt;20 Mins): In heavy rain, low-elevation underpass sag points drown before traffic police can deploy physical barricades.</a:t>
+            </a:r>
+          </a:p>
+          <a:p>
+            <a:pPr>
+              <a:spcBef>
+                <a:spcPts val="300"/>
+              </a:spcBef>
+              <a:defRPr sz="850">
+                <a:solidFill>
+                  <a:srgbClr val="1E293B"/>
+                </a:solidFill>
+              </a:defRPr>
+            </a:pPr>
+            <a:r>
+              <a:t>• Consumer Navigation Deficiency: Google Maps only reflects traffic slowdown after vehicles have already stalled; zero capability to detect live water depth or displaced manholes.</a:t>
+            </a:r>
+          </a:p>
+          <a:p>
+            <a:pPr>
+              <a:spcBef>
+                <a:spcPts val="300"/>
+              </a:spcBef>
+              <a:defRPr sz="850">
+                <a:solidFill>
+                  <a:srgbClr val="1E293B"/>
+                </a:solidFill>
+              </a:defRPr>
+            </a:pPr>
+            <a:r>
+              <a:t>• Civic Macro-Alert Limitations: City-wide IMD 'Yellow/Orange/Red' weather alerts lack street-level granularity; commuters cannot determine which specific underpass or lane is submerged.</a:t>
             </a:r>
           </a:p>
         </p:txBody>

</xml_diff>

<commit_message>
Clarify Box 4 on Slide 2: ZERO WARNING (Commuters Drive in Blind)
</commit_message>
<xml_diff>
--- a/presentation/RainRoute_Vishwakarma_Stage2_Deck.pptx
+++ b/presentation/RainRoute_Vishwakarma_Stage2_Deck.pptx
@@ -10069,30 +10069,45 @@
           </a:fontRef>
         </p:style>
         <p:txBody>
-          <a:bodyPr rtlCol="0" anchor="ctr"/>
+          <a:bodyPr rtlCol="0" anchor="ctr" wrap="square"/>
           <a:lstStyle/>
           <a:p>
             <a:pPr algn="ctr">
-              <a:defRPr sz="1900" b="1">
+              <a:defRPr sz="1700" b="1">
+                <a:solidFill>
+                  <a:srgbClr val="DC2626"/>
+                </a:solidFill>
+              </a:defRPr>
+            </a:pPr>
+            <a:r>
+              <a:t>ZERO WARNING</a:t>
+            </a:r>
+          </a:p>
+          <a:p>
+            <a:pPr>
+              <a:spcBef>
+                <a:spcPts val="200"/>
+              </a:spcBef>
+              <a:defRPr sz="750" b="1">
                 <a:solidFill>
                   <a:srgbClr val="0F2341"/>
                 </a:solidFill>
               </a:defRPr>
             </a:pPr>
             <a:r>
-              <a:t>0 Min</a:t>
-            </a:r>
-          </a:p>
-          <a:p>
-            <a:pPr algn="ctr">
-              <a:defRPr sz="750" b="1">
+              <a:t>COMMUTERS DRIVE IN BLIND</a:t>
+            </a:r>
+          </a:p>
+          <a:p>
+            <a:pPr>
+              <a:defRPr sz="650">
                 <a:solidFill>
                   <a:srgbClr val="64748B"/>
                 </a:solidFill>
               </a:defRPr>
             </a:pPr>
             <a:r>
-              <a:t>PRIOR ROAD-LEVEL WARNING</a:t>
+              <a:t>No Water Depth on Existing Maps</a:t>
             </a:r>
           </a:p>
         </p:txBody>

</xml_diff>